<commit_message>
github repo added to the presentation
</commit_message>
<xml_diff>
--- a/presentation.pptx
+++ b/presentation.pptx
@@ -5140,7 +5140,7 @@
           <a:p>
             <a:fld id="{9E497948-54D2-43F8-9A63-A99FE3051738}" type="datetimeFigureOut">
               <a:rPr lang="en-US" smtClean="0"/>
-              <a:t>8/7/2026</a:t>
+              <a:t>8/8/2026</a:t>
             </a:fld>
             <a:endParaRPr lang="en-US"/>
           </a:p>
@@ -9473,20 +9473,22 @@
             <a:r>
               <a:rPr lang="en-US" sz="2000" noProof="0" dirty="0">
                 <a:solidFill>
-                  <a:schemeClr val="bg1">
-                    <a:lumMod val="75000"/>
-                  </a:schemeClr>
+                  <a:schemeClr val="tx1"/>
                 </a:solidFill>
                 <a:latin typeface="IBM Plex Mono Medium" panose="020B0609050203000203" pitchFamily="49" charset="0"/>
-                <a:hlinkClick r:id="rId3"/>
+                <a:hlinkClick r:id="rId3">
+                  <a:extLst>
+                    <a:ext uri="{A12FA001-AC4F-418D-AE19-62706E023703}">
+                      <ahyp:hlinkClr xmlns:ahyp="http://schemas.microsoft.com/office/drawing/2018/hyperlinkcolor" val="tx"/>
+                    </a:ext>
+                  </a:extLst>
+                </a:hlinkClick>
               </a:rPr>
               <a:t>https://github.com/ali-can-turan</a:t>
             </a:r>
             <a:endParaRPr lang="en-US" sz="2000" noProof="0" dirty="0">
               <a:solidFill>
-                <a:schemeClr val="bg1">
-                  <a:lumMod val="75000"/>
-                </a:schemeClr>
+                <a:schemeClr val="tx1"/>
               </a:solidFill>
               <a:latin typeface="IBM Plex Mono Medium" panose="020B0609050203000203" pitchFamily="49" charset="0"/>
             </a:endParaRPr>
@@ -9496,10 +9498,18 @@
               <a:buNone/>
             </a:pPr>
             <a:r>
-              <a:rPr lang="en-US" sz="2000" u="sng" noProof="0" dirty="0"/>
+              <a:rPr lang="en-US" sz="2000" u="sng" noProof="0" dirty="0">
+                <a:solidFill>
+                  <a:schemeClr val="tx1"/>
+                </a:solidFill>
+              </a:rPr>
               <a:t>ali.can.turan@outlook.com</a:t>
             </a:r>
-            <a:endParaRPr lang="en-US" sz="2000" noProof="0" dirty="0"/>
+            <a:endParaRPr lang="en-US" sz="2000" noProof="0" dirty="0">
+              <a:solidFill>
+                <a:schemeClr val="tx1"/>
+              </a:solidFill>
+            </a:endParaRPr>
           </a:p>
         </p:txBody>
       </p:sp>
@@ -12288,213 +12298,6 @@
           </a:p>
         </p:txBody>
       </p:sp>
-      <p:sp>
-        <p:nvSpPr>
-          <p:cNvPr id="3" name="Content Placeholder 2">
-            <a:extLst>
-              <a:ext uri="{FF2B5EF4-FFF2-40B4-BE49-F238E27FC236}">
-                <a16:creationId xmlns:a16="http://schemas.microsoft.com/office/drawing/2014/main" id="{25C64183-B387-01E7-21BA-4DA6B1F51815}"/>
-              </a:ext>
-            </a:extLst>
-          </p:cNvPr>
-          <p:cNvSpPr txBox="1">
-            <a:spLocks/>
-          </p:cNvSpPr>
-          <p:nvPr/>
-        </p:nvSpPr>
-        <p:spPr>
-          <a:xfrm>
-            <a:off x="3815757" y="5165541"/>
-            <a:ext cx="1506125" cy="439190"/>
-          </a:xfrm>
-          <a:prstGeom prst="rect">
-            <a:avLst/>
-          </a:prstGeom>
-        </p:spPr>
-        <p:txBody>
-          <a:bodyPr vert="horz" lIns="91440" tIns="45720" rIns="91440" bIns="45720" rtlCol="0">
-            <a:normAutofit/>
-          </a:bodyPr>
-          <a:lstStyle>
-            <a:lvl1pPr marL="228600" indent="-228600" algn="l" defTabSz="914400" rtl="0" eaLnBrk="1" latinLnBrk="0" hangingPunct="1">
-              <a:lnSpc>
-                <a:spcPct val="90000"/>
-              </a:lnSpc>
-              <a:spcBef>
-                <a:spcPts val="1000"/>
-              </a:spcBef>
-              <a:buFont typeface="Arial"/>
-              <a:buChar char="•"/>
-              <a:defRPr sz="2800" kern="1200">
-                <a:solidFill>
-                  <a:srgbClr val="262626"/>
-                </a:solidFill>
-                <a:latin typeface="IBM Plex Sans" panose="020B0503050203000203" pitchFamily="34" charset="0"/>
-                <a:ea typeface="+mn-ea"/>
-                <a:cs typeface="+mn-cs"/>
-              </a:defRPr>
-            </a:lvl1pPr>
-            <a:lvl2pPr marL="685800" indent="-228600" algn="l" defTabSz="914400" rtl="0" eaLnBrk="1" latinLnBrk="0" hangingPunct="1">
-              <a:lnSpc>
-                <a:spcPct val="90000"/>
-              </a:lnSpc>
-              <a:spcBef>
-                <a:spcPts val="500"/>
-              </a:spcBef>
-              <a:buFont typeface="Arial"/>
-              <a:buChar char="•"/>
-              <a:defRPr sz="2400" kern="1200">
-                <a:solidFill>
-                  <a:srgbClr val="262626"/>
-                </a:solidFill>
-                <a:latin typeface="IBM Plex Sans" panose="020B0503050203000203" pitchFamily="34" charset="0"/>
-                <a:ea typeface="+mn-ea"/>
-                <a:cs typeface="+mn-cs"/>
-              </a:defRPr>
-            </a:lvl2pPr>
-            <a:lvl3pPr marL="1143000" indent="-228600" algn="l" defTabSz="914400" rtl="0" eaLnBrk="1" latinLnBrk="0" hangingPunct="1">
-              <a:lnSpc>
-                <a:spcPct val="90000"/>
-              </a:lnSpc>
-              <a:spcBef>
-                <a:spcPts val="500"/>
-              </a:spcBef>
-              <a:buFont typeface="Arial"/>
-              <a:buChar char="•"/>
-              <a:defRPr sz="2000" kern="1200">
-                <a:solidFill>
-                  <a:srgbClr val="262626"/>
-                </a:solidFill>
-                <a:latin typeface="IBM Plex Sans" panose="020B0503050203000203" pitchFamily="34" charset="0"/>
-                <a:ea typeface="+mn-ea"/>
-                <a:cs typeface="+mn-cs"/>
-              </a:defRPr>
-            </a:lvl3pPr>
-            <a:lvl4pPr marL="1600200" indent="-228600" algn="l" defTabSz="914400" rtl="0" eaLnBrk="1" latinLnBrk="0" hangingPunct="1">
-              <a:lnSpc>
-                <a:spcPct val="90000"/>
-              </a:lnSpc>
-              <a:spcBef>
-                <a:spcPts val="500"/>
-              </a:spcBef>
-              <a:buFont typeface="Arial"/>
-              <a:buChar char="•"/>
-              <a:defRPr sz="1800" kern="1200">
-                <a:solidFill>
-                  <a:srgbClr val="525252"/>
-                </a:solidFill>
-                <a:latin typeface="IBM Plex Sans" panose="020B0503050203000203" pitchFamily="34" charset="0"/>
-                <a:ea typeface="+mn-ea"/>
-                <a:cs typeface="+mn-cs"/>
-              </a:defRPr>
-            </a:lvl4pPr>
-            <a:lvl5pPr marL="2057400" indent="-228600" algn="l" defTabSz="914400" rtl="0" eaLnBrk="1" latinLnBrk="0" hangingPunct="1">
-              <a:lnSpc>
-                <a:spcPct val="90000"/>
-              </a:lnSpc>
-              <a:spcBef>
-                <a:spcPts val="500"/>
-              </a:spcBef>
-              <a:buFont typeface="Arial"/>
-              <a:buChar char="•"/>
-              <a:defRPr sz="1800" kern="1200">
-                <a:solidFill>
-                  <a:srgbClr val="525252"/>
-                </a:solidFill>
-                <a:latin typeface="IBM Plex Sans" panose="020B0503050203000203" pitchFamily="34" charset="0"/>
-                <a:ea typeface="+mn-ea"/>
-                <a:cs typeface="+mn-cs"/>
-              </a:defRPr>
-            </a:lvl5pPr>
-            <a:lvl6pPr marL="2514600" indent="-228600" algn="l" defTabSz="914400" rtl="0" eaLnBrk="1" latinLnBrk="0" hangingPunct="1">
-              <a:lnSpc>
-                <a:spcPct val="90000"/>
-              </a:lnSpc>
-              <a:spcBef>
-                <a:spcPts val="500"/>
-              </a:spcBef>
-              <a:buFont typeface="Arial"/>
-              <a:buChar char="•"/>
-              <a:defRPr sz="1800" kern="1200">
-                <a:solidFill>
-                  <a:schemeClr val="tx1"/>
-                </a:solidFill>
-                <a:latin typeface="+mn-lt"/>
-                <a:ea typeface="+mn-ea"/>
-                <a:cs typeface="+mn-cs"/>
-              </a:defRPr>
-            </a:lvl6pPr>
-            <a:lvl7pPr marL="2971800" indent="-228600" algn="l" defTabSz="914400" rtl="0" eaLnBrk="1" latinLnBrk="0" hangingPunct="1">
-              <a:lnSpc>
-                <a:spcPct val="90000"/>
-              </a:lnSpc>
-              <a:spcBef>
-                <a:spcPts val="500"/>
-              </a:spcBef>
-              <a:buFont typeface="Arial"/>
-              <a:buChar char="•"/>
-              <a:defRPr sz="1800" kern="1200">
-                <a:solidFill>
-                  <a:schemeClr val="tx1"/>
-                </a:solidFill>
-                <a:latin typeface="+mn-lt"/>
-                <a:ea typeface="+mn-ea"/>
-                <a:cs typeface="+mn-cs"/>
-              </a:defRPr>
-            </a:lvl7pPr>
-            <a:lvl8pPr marL="3429000" indent="-228600" algn="l" defTabSz="914400" rtl="0" eaLnBrk="1" latinLnBrk="0" hangingPunct="1">
-              <a:lnSpc>
-                <a:spcPct val="90000"/>
-              </a:lnSpc>
-              <a:spcBef>
-                <a:spcPts val="500"/>
-              </a:spcBef>
-              <a:buFont typeface="Arial"/>
-              <a:buChar char="•"/>
-              <a:defRPr sz="1800" kern="1200">
-                <a:solidFill>
-                  <a:schemeClr val="tx1"/>
-                </a:solidFill>
-                <a:latin typeface="+mn-lt"/>
-                <a:ea typeface="+mn-ea"/>
-                <a:cs typeface="+mn-cs"/>
-              </a:defRPr>
-            </a:lvl8pPr>
-            <a:lvl9pPr marL="3886200" indent="-228600" algn="l" defTabSz="914400" rtl="0" eaLnBrk="1" latinLnBrk="0" hangingPunct="1">
-              <a:lnSpc>
-                <a:spcPct val="90000"/>
-              </a:lnSpc>
-              <a:spcBef>
-                <a:spcPts val="500"/>
-              </a:spcBef>
-              <a:buFont typeface="Arial"/>
-              <a:buChar char="•"/>
-              <a:defRPr sz="1800" kern="1200">
-                <a:solidFill>
-                  <a:schemeClr val="tx1"/>
-                </a:solidFill>
-                <a:latin typeface="+mn-lt"/>
-                <a:ea typeface="+mn-ea"/>
-                <a:cs typeface="+mn-cs"/>
-              </a:defRPr>
-            </a:lvl9pPr>
-          </a:lstStyle>
-          <a:p>
-            <a:pPr marL="0" indent="0">
-              <a:buFont typeface="Arial"/>
-              <a:buNone/>
-            </a:pPr>
-            <a:r>
-              <a:rPr lang="en-US" sz="2200" noProof="0" dirty="0" err="1"/>
-              <a:t>github</a:t>
-            </a:r>
-            <a:r>
-              <a:rPr lang="en-US" sz="2200" noProof="0" dirty="0"/>
-              <a:t> link</a:t>
-            </a:r>
-          </a:p>
-        </p:txBody>
-      </p:sp>
       <p:pic>
         <p:nvPicPr>
           <p:cNvPr id="4" name="Picture 3">
@@ -12525,6 +12328,50 @@
           </a:prstGeom>
         </p:spPr>
       </p:pic>
+      <p:sp>
+        <p:nvSpPr>
+          <p:cNvPr id="6" name="TextBox 5">
+            <a:extLst>
+              <a:ext uri="{FF2B5EF4-FFF2-40B4-BE49-F238E27FC236}">
+                <a16:creationId xmlns:a16="http://schemas.microsoft.com/office/drawing/2014/main" id="{FA7790F5-595C-3339-E589-708E77007FDA}"/>
+              </a:ext>
+            </a:extLst>
+          </p:cNvPr>
+          <p:cNvSpPr txBox="1"/>
+          <p:nvPr/>
+        </p:nvSpPr>
+        <p:spPr>
+          <a:xfrm>
+            <a:off x="2743200" y="4780993"/>
+            <a:ext cx="6705600" cy="461665"/>
+          </a:xfrm>
+          <a:prstGeom prst="rect">
+            <a:avLst/>
+          </a:prstGeom>
+          <a:noFill/>
+        </p:spPr>
+        <p:txBody>
+          <a:bodyPr wrap="square">
+            <a:spAutoFit/>
+          </a:bodyPr>
+          <a:lstStyle/>
+          <a:p>
+            <a:r>
+              <a:rPr lang="tr-TR" sz="2400" dirty="0">
+                <a:hlinkClick r:id="rId4">
+                  <a:extLst>
+                    <a:ext uri="{A12FA001-AC4F-418D-AE19-62706E023703}">
+                      <ahyp:hlinkClr xmlns:ahyp="http://schemas.microsoft.com/office/drawing/2018/hyperlinkcolor" val="tx"/>
+                    </a:ext>
+                  </a:extLst>
+                </a:hlinkClick>
+              </a:rPr>
+              <a:t>https://github.com/ali-can-turan/ibm-capstone</a:t>
+            </a:r>
+            <a:endParaRPr lang="en-US" sz="2400" noProof="0" dirty="0"/>
+          </a:p>
+        </p:txBody>
+      </p:sp>
     </p:spTree>
     <p:custDataLst>
       <p:tags r:id="rId1"/>
@@ -31677,8 +31524,8 @@
         </p:nvSpPr>
         <p:spPr>
           <a:xfrm>
-            <a:off x="3505200" y="4780993"/>
-            <a:ext cx="7413336" cy="461665"/>
+            <a:off x="2743200" y="4780993"/>
+            <a:ext cx="6705600" cy="461665"/>
           </a:xfrm>
           <a:prstGeom prst="rect">
             <a:avLst/>
@@ -31691,13 +31538,17 @@
           </a:bodyPr>
           <a:lstStyle/>
           <a:p>
-            <a:pPr marL="0" indent="0">
-              <a:buFont typeface="Arial"/>
-              <a:buNone/>
-            </a:pPr>
-            <a:r>
-              <a:rPr lang="tr-TR" sz="2400" noProof="0" dirty="0" err="1"/>
-              <a:t>github</a:t>
+            <a:r>
+              <a:rPr lang="tr-TR" sz="2400" dirty="0">
+                <a:hlinkClick r:id="rId4">
+                  <a:extLst>
+                    <a:ext uri="{A12FA001-AC4F-418D-AE19-62706E023703}">
+                      <ahyp:hlinkClr xmlns:ahyp="http://schemas.microsoft.com/office/drawing/2018/hyperlinkcolor" val="tx"/>
+                    </a:ext>
+                  </a:extLst>
+                </a:hlinkClick>
+              </a:rPr>
+              <a:t>https://github.com/ali-can-turan/ibm-capstone</a:t>
             </a:r>
             <a:endParaRPr lang="en-US" sz="2400" noProof="0" dirty="0"/>
           </a:p>
@@ -34357,6 +34208,18 @@
 </file>
 
 <file path=customXml/item1.xml><?xml version="1.0" encoding="utf-8"?>
+<p:properties xmlns:p="http://schemas.microsoft.com/office/2006/metadata/properties" xmlns:xsi="http://www.w3.org/2001/XMLSchema-instance" xmlns:pc="http://schemas.microsoft.com/office/infopath/2007/PartnerControls">
+  <documentManagement>
+    <lcf76f155ced4ddcb4097134ff3c332f xmlns="155be751-a274-42e8-93fb-f39d3b9bccc8">
+      <Terms xmlns="http://schemas.microsoft.com/office/infopath/2007/PartnerControls"/>
+    </lcf76f155ced4ddcb4097134ff3c332f>
+    <TaxCatchAll xmlns="f80a141d-92ca-4d3d-9308-f7e7b1d44ce8" xsi:nil="true"/>
+    <AWBlink xmlns="155be751-a274-42e8-93fb-f39d3b9bccc8" xsi:nil="true"/>
+  </documentManagement>
+</p:properties>
+</file>
+
+<file path=customXml/item2.xml><?xml version="1.0" encoding="utf-8"?>
 <ct:contentTypeSchema xmlns:ct="http://schemas.microsoft.com/office/2006/metadata/contentType" xmlns:ma="http://schemas.microsoft.com/office/2006/metadata/properties/metaAttributes" ct:_="" ma:_="" ma:contentTypeName="Document" ma:contentTypeID="0x010100EECD86F56755A646AC8AFCBCBD967F21" ma:contentTypeVersion="19" ma:contentTypeDescription="Create a new document." ma:contentTypeScope="" ma:versionID="d7279d4efbac013e02c1e816bc7f7c13">
   <xsd:schema xmlns:xsd="http://www.w3.org/2001/XMLSchema" xmlns:xs="http://www.w3.org/2001/XMLSchema" xmlns:p="http://schemas.microsoft.com/office/2006/metadata/properties" xmlns:ns2="155be751-a274-42e8-93fb-f39d3b9bccc8" xmlns:ns3="f80a141d-92ca-4d3d-9308-f7e7b1d44ce8" targetNamespace="http://schemas.microsoft.com/office/2006/metadata/properties" ma:root="true" ma:fieldsID="0a3fd1dbe83fc08387abb87098562ef0" ns2:_="" ns3:_="">
     <xsd:import namespace="155be751-a274-42e8-93fb-f39d3b9bccc8"/>
@@ -34613,18 +34476,6 @@
 </ct:contentTypeSchema>
 </file>
 
-<file path=customXml/item2.xml><?xml version="1.0" encoding="utf-8"?>
-<p:properties xmlns:p="http://schemas.microsoft.com/office/2006/metadata/properties" xmlns:xsi="http://www.w3.org/2001/XMLSchema-instance" xmlns:pc="http://schemas.microsoft.com/office/infopath/2007/PartnerControls">
-  <documentManagement>
-    <lcf76f155ced4ddcb4097134ff3c332f xmlns="155be751-a274-42e8-93fb-f39d3b9bccc8">
-      <Terms xmlns="http://schemas.microsoft.com/office/infopath/2007/PartnerControls"/>
-    </lcf76f155ced4ddcb4097134ff3c332f>
-    <TaxCatchAll xmlns="f80a141d-92ca-4d3d-9308-f7e7b1d44ce8" xsi:nil="true"/>
-    <AWBlink xmlns="155be751-a274-42e8-93fb-f39d3b9bccc8" xsi:nil="true"/>
-  </documentManagement>
-</p:properties>
-</file>
-
 <file path=customXml/item3.xml><?xml version="1.0" encoding="utf-8"?>
 <?mso-contentType ?>
 <FormTemplates xmlns="http://schemas.microsoft.com/sharepoint/v3/contenttype/forms">
@@ -34635,6 +34486,23 @@
 </file>
 
 <file path=customXml/itemProps1.xml><?xml version="1.0" encoding="utf-8"?>
+<ds:datastoreItem xmlns:ds="http://schemas.openxmlformats.org/officeDocument/2006/customXml" ds:itemID="{54DA07C5-A406-4A0D-B3E6-3856C94AC7F3}">
+  <ds:schemaRefs>
+    <ds:schemaRef ds:uri="155be751-a274-42e8-93fb-f39d3b9bccc8"/>
+    <ds:schemaRef ds:uri="http://purl.org/dc/elements/1.1/"/>
+    <ds:schemaRef ds:uri="http://schemas.microsoft.com/office/2006/metadata/properties"/>
+    <ds:schemaRef ds:uri="http://schemas.microsoft.com/office/2006/documentManagement/types"/>
+    <ds:schemaRef ds:uri="http://schemas.openxmlformats.org/package/2006/metadata/core-properties"/>
+    <ds:schemaRef ds:uri="http://purl.org/dc/dcmitype/"/>
+    <ds:schemaRef ds:uri="http://schemas.microsoft.com/office/infopath/2007/PartnerControls"/>
+    <ds:schemaRef ds:uri="f80a141d-92ca-4d3d-9308-f7e7b1d44ce8"/>
+    <ds:schemaRef ds:uri="http://www.w3.org/XML/1998/namespace"/>
+    <ds:schemaRef ds:uri="http://purl.org/dc/terms/"/>
+  </ds:schemaRefs>
+</ds:datastoreItem>
+</file>
+
+<file path=customXml/itemProps2.xml><?xml version="1.0" encoding="utf-8"?>
 <ds:datastoreItem xmlns:ds="http://schemas.openxmlformats.org/officeDocument/2006/customXml" ds:itemID="{BEAB06F8-DBB4-44C7-AF84-8B098C8B039F}">
   <ds:schemaRefs>
     <ds:schemaRef ds:uri="http://schemas.microsoft.com/office/2006/metadata/contentType"/>
@@ -34653,23 +34521,6 @@
 </ds:datastoreItem>
 </file>
 
-<file path=customXml/itemProps2.xml><?xml version="1.0" encoding="utf-8"?>
-<ds:datastoreItem xmlns:ds="http://schemas.openxmlformats.org/officeDocument/2006/customXml" ds:itemID="{54DA07C5-A406-4A0D-B3E6-3856C94AC7F3}">
-  <ds:schemaRefs>
-    <ds:schemaRef ds:uri="155be751-a274-42e8-93fb-f39d3b9bccc8"/>
-    <ds:schemaRef ds:uri="http://purl.org/dc/elements/1.1/"/>
-    <ds:schemaRef ds:uri="http://schemas.microsoft.com/office/2006/metadata/properties"/>
-    <ds:schemaRef ds:uri="http://schemas.microsoft.com/office/2006/documentManagement/types"/>
-    <ds:schemaRef ds:uri="http://schemas.openxmlformats.org/package/2006/metadata/core-properties"/>
-    <ds:schemaRef ds:uri="http://purl.org/dc/dcmitype/"/>
-    <ds:schemaRef ds:uri="http://schemas.microsoft.com/office/infopath/2007/PartnerControls"/>
-    <ds:schemaRef ds:uri="f80a141d-92ca-4d3d-9308-f7e7b1d44ce8"/>
-    <ds:schemaRef ds:uri="http://www.w3.org/XML/1998/namespace"/>
-    <ds:schemaRef ds:uri="http://purl.org/dc/terms/"/>
-  </ds:schemaRefs>
-</ds:datastoreItem>
-</file>
-
 <file path=customXml/itemProps3.xml><?xml version="1.0" encoding="utf-8"?>
 <ds:datastoreItem xmlns:ds="http://schemas.openxmlformats.org/officeDocument/2006/customXml" ds:itemID="{7EFDA260-DDA0-422C-B7AE-778F653FBB36}">
   <ds:schemaRefs>

</xml_diff>